<commit_message>
lesson: clarify the complete-context decision
</commit_message>
<xml_diff>
--- a/decks/03-cag-financial-document.pptx
+++ b/decks/03-cag-financial-document.pptx
@@ -2,19 +2,19 @@
 <file path=ppt/presentation.xml><?xml version="1.0" encoding="utf-8"?>
 <p:presentation xmlns:p="http://schemas.openxmlformats.org/presentationml/2006/main">
   <p:sldMasterIdLst>
-    <p:sldMasterId xmlns:r="http://schemas.openxmlformats.org/officeDocument/2006/relationships" id="2147483648" r:id="R9a1a195022354c97"/>
+    <p:sldMasterId xmlns:r="http://schemas.openxmlformats.org/officeDocument/2006/relationships" id="2147483648" r:id="Rfe92902160a44f93"/>
   </p:sldMasterIdLst>
   <p:notesMasterIdLst>
-    <p:notesMasterId xmlns:r="http://schemas.openxmlformats.org/officeDocument/2006/relationships" r:id="Rf81ecdf2599d4ea3"/>
+    <p:notesMasterId xmlns:r="http://schemas.openxmlformats.org/officeDocument/2006/relationships" r:id="Rcd8245817adf417a"/>
   </p:notesMasterIdLst>
   <p:sldIdLst>
-    <p:sldId xmlns:r="http://schemas.openxmlformats.org/officeDocument/2006/relationships" id="256" r:id="R3357926226ce4e81"/>
-    <p:sldId xmlns:r="http://schemas.openxmlformats.org/officeDocument/2006/relationships" id="257" r:id="Re55b7b5cbd98475b"/>
-    <p:sldId xmlns:r="http://schemas.openxmlformats.org/officeDocument/2006/relationships" id="258" r:id="Ra239a3e9b62c49fc"/>
-    <p:sldId xmlns:r="http://schemas.openxmlformats.org/officeDocument/2006/relationships" id="259" r:id="R659fd9eccc034404"/>
-    <p:sldId xmlns:r="http://schemas.openxmlformats.org/officeDocument/2006/relationships" id="260" r:id="R55bfef7c2b0e4e6d"/>
-    <p:sldId xmlns:r="http://schemas.openxmlformats.org/officeDocument/2006/relationships" id="261" r:id="R1e1a816a53af4b57"/>
-    <p:sldId xmlns:r="http://schemas.openxmlformats.org/officeDocument/2006/relationships" id="262" r:id="R6456ac5e49ca4111"/>
+    <p:sldId xmlns:r="http://schemas.openxmlformats.org/officeDocument/2006/relationships" id="256" r:id="R4d24a3c99801437a"/>
+    <p:sldId xmlns:r="http://schemas.openxmlformats.org/officeDocument/2006/relationships" id="257" r:id="R610eba24c6ef4c32"/>
+    <p:sldId xmlns:r="http://schemas.openxmlformats.org/officeDocument/2006/relationships" id="258" r:id="R51bc08969ac5430a"/>
+    <p:sldId xmlns:r="http://schemas.openxmlformats.org/officeDocument/2006/relationships" id="259" r:id="R3cb08bfdbc4f45d4"/>
+    <p:sldId xmlns:r="http://schemas.openxmlformats.org/officeDocument/2006/relationships" id="260" r:id="Rb844df666a864661"/>
+    <p:sldId xmlns:r="http://schemas.openxmlformats.org/officeDocument/2006/relationships" id="261" r:id="Rb9c1aed71d8940bd"/>
+    <p:sldId xmlns:r="http://schemas.openxmlformats.org/officeDocument/2006/relationships" id="262" r:id="R02b38c7974334bb7"/>
   </p:sldIdLst>
   <p:sldSz cx="15240000" cy="8572500"/>
   <p:notesSz cx="6858000" cy="9144000"/>
@@ -448,7 +448,7 @@
           <a:lstStyle xmlns:a="http://schemas.openxmlformats.org/drawingml/2006/main"/>
           <a:p xmlns:a="http://schemas.openxmlformats.org/drawingml/2006/main">
             <a:r>
-              <a:t>Open with the engineering question: when is the simplest complete-document path sufficient, and when must the application retrieve evidence?</a:t>
+              <a:t>Connect structured outputs to the next application boundary: which source information enters each call.</a:t>
             </a:r>
           </a:p>
           <a:p xmlns:a="http://schemas.openxmlformats.org/drawingml/2006/main">
@@ -464,6 +464,11 @@
           <a:p xmlns:a="http://schemas.openxmlformats.org/drawingml/2006/main">
             <a:r>
               <a:t>- https://www.sec.gov/Archives/edgar/data/1045810/000104581026000021/nvda-20260125.htm</a:t>
+            </a:r>
+          </a:p>
+          <a:p xmlns:a="http://schemas.openxmlformats.org/drawingml/2006/main">
+            <a:r>
+              <a:t>- https://developers.openai.com/api/docs/guides/prompt-caching</a:t>
             </a:r>
           </a:p>
           <a:p xmlns:a="http://schemas.openxmlformats.org/drawingml/2006/main">
@@ -538,7 +543,7 @@
           <a:lstStyle xmlns:a="http://schemas.openxmlformats.org/drawingml/2006/main"/>
           <a:p xmlns:a="http://schemas.openxmlformats.org/drawingml/2006/main">
             <a:r>
-              <a:t>Separate context engineering from prompt wording. Walk through every token consumer, including the answer reservation.</a:t>
+              <a:t>Name the five mechanisms. Context supplies information now; Cache reuses a prefix; Memory retains state; Grounding checks evidence support; RAG selects evidence.</a:t>
             </a:r>
           </a:p>
           <a:p xmlns:a="http://schemas.openxmlformats.org/drawingml/2006/main">
@@ -554,6 +559,16 @@
           <a:p xmlns:a="http://schemas.openxmlformats.org/drawingml/2006/main">
             <a:r>
               <a:t>- https://developers.openai.com/api/docs/guides/prompt-caching</a:t>
+            </a:r>
+          </a:p>
+          <a:p xmlns:a="http://schemas.openxmlformats.org/drawingml/2006/main">
+            <a:r>
+              <a:t>- https://docs.langchain.com/oss/python/langgraph/add-memory</a:t>
+            </a:r>
+          </a:p>
+          <a:p xmlns:a="http://schemas.openxmlformats.org/drawingml/2006/main">
+            <a:r>
+              <a:t>- https://arxiv.org/abs/2005.11401</a:t>
             </a:r>
           </a:p>
           <a:p xmlns:a="http://schemas.openxmlformats.org/drawingml/2006/main">
@@ -628,7 +643,7 @@
           <a:lstStyle xmlns:a="http://schemas.openxmlformats.org/drawingml/2006/main"/>
           <a:p xmlns:a="http://schemas.openxmlformats.org/drawingml/2006/main">
             <a:r>
-              <a:t>Use this as the central architecture diagram. The budget gate is deterministic; grounding is verified after the model response.</a:t>
+              <a:t>Read ContextDecision as a typed application record: estimated input, available capacity, route and reason are produced before generation.</a:t>
             </a:r>
           </a:p>
           <a:p xmlns:a="http://schemas.openxmlformats.org/drawingml/2006/main">
@@ -643,7 +658,7 @@
           </a:p>
           <a:p xmlns:a="http://schemas.openxmlformats.org/drawingml/2006/main">
             <a:r>
-              <a:t>- https://www.sec.gov/Archives/edgar/data/1045810/000104581026000021/nvda-20260125.htm</a:t>
+              <a:t>- https://developers.openai.com/api/docs/guides/prompt-caching</a:t>
             </a:r>
           </a:p>
           <a:p xmlns:a="http://schemas.openxmlformats.org/drawingml/2006/main">
@@ -718,7 +733,7 @@
           <a:lstStyle xmlns:a="http://schemas.openxmlformats.org/drawingml/2006/main"/>
           <a:p xmlns:a="http://schemas.openxmlformats.org/drawingml/2006/main">
             <a:r>
-              <a:t>Exact prefix reuse is the portable design rule. A provider cache is an efficiency feature; inspect returned usage metadata before claiming a hit.</a:t>
+              <a:t>Only the stable prefix is reusable. The answer is generated for each question, and latency alone does not prove a cache hit.</a:t>
             </a:r>
           </a:p>
           <a:p xmlns:a="http://schemas.openxmlformats.org/drawingml/2006/main">
@@ -808,7 +823,7 @@
           <a:lstStyle xmlns:a="http://schemas.openxmlformats.org/drawingml/2006/main"/>
           <a:p xmlns:a="http://schemas.openxmlformats.org/drawingml/2006/main">
             <a:r>
-              <a:t>Distinguish capacity from attention. The cited study found that performance can vary with the position of relevant information in long contexts.</a:t>
+              <a:t>A context window is capacity, not guaranteed attention. Separate the deterministic budget gate from empirical question-level evaluation.</a:t>
             </a:r>
           </a:p>
           <a:p xmlns:a="http://schemas.openxmlformats.org/drawingml/2006/main">
@@ -824,11 +839,6 @@
           <a:p xmlns:a="http://schemas.openxmlformats.org/drawingml/2006/main">
             <a:r>
               <a:t>- https://arxiv.org/abs/2307.03172</a:t>
-            </a:r>
-          </a:p>
-          <a:p xmlns:a="http://schemas.openxmlformats.org/drawingml/2006/main">
-            <a:r>
-              <a:t>- https://developers.openai.com/api/docs/guides/prompt-caching</a:t>
             </a:r>
           </a:p>
           <a:p xmlns:a="http://schemas.openxmlformats.org/drawingml/2006/main">
@@ -903,7 +913,7 @@
           <a:lstStyle xmlns:a="http://schemas.openxmlformats.org/drawingml/2006/main"/>
           <a:p xmlns:a="http://schemas.openxmlformats.org/drawingml/2006/main">
             <a:r>
-              <a:t>Ask the class to choose the route for a single annual report, then for several years and companies. Record the route before generation.</a:t>
+              <a:t>Use complete context for one bounded stable source; use retrieval when evidence must be selected from a large or changing corpus.</a:t>
             </a:r>
           </a:p>
           <a:p xmlns:a="http://schemas.openxmlformats.org/drawingml/2006/main">
@@ -914,6 +924,11 @@
           <a:p xmlns:a="http://schemas.openxmlformats.org/drawingml/2006/main">
             <a:r>
               <a:t>[Sources]</a:t>
+            </a:r>
+          </a:p>
+          <a:p xmlns:a="http://schemas.openxmlformats.org/drawingml/2006/main">
+            <a:r>
+              <a:t>- https://arxiv.org/abs/2005.11401</a:t>
             </a:r>
           </a:p>
           <a:p xmlns:a="http://schemas.openxmlformats.org/drawingml/2006/main">
@@ -993,7 +1008,7 @@
           <a:lstStyle xmlns:a="http://schemas.openxmlformats.org/drawingml/2006/main"/>
           <a:p xmlns:a="http://schemas.openxmlformats.org/drawingml/2006/main">
             <a:r>
-              <a:t>Move into Notebook 03. Students will produce five figures, make two model calls and observe the budget gate reject a longer stress document.</a:t>
+              <a:t>Move into the notebook: budget the NVIDIA extract, inspect ContextDecision, measure two calls, then force an explicit RAG route.</a:t>
             </a:r>
           </a:p>
           <a:p xmlns:a="http://schemas.openxmlformats.org/drawingml/2006/main">
@@ -1014,11 +1029,6 @@
           <a:p xmlns:a="http://schemas.openxmlformats.org/drawingml/2006/main">
             <a:r>
               <a:t>- https://developers.openai.com/api/docs/guides/prompt-caching</a:t>
-            </a:r>
-          </a:p>
-          <a:p xmlns:a="http://schemas.openxmlformats.org/drawingml/2006/main">
-            <a:r>
-              <a:t>- https://arxiv.org/abs/2307.03172</a:t>
             </a:r>
           </a:p>
           <a:p xmlns:a="http://schemas.openxmlformats.org/drawingml/2006/main">
@@ -1091,7 +1101,7 @@
   </p:cSld>
   <p:clrMap bg1="lt1" tx1="dk1" bg2="lt2" tx2="dk2" accent1="accent1" accent2="accent2" accent3="accent3" accent4="accent4" accent5="accent5" accent6="accent6" hlink="hlink" folHlink="folHlink"/>
   <p:sldLayoutIdLst>
-    <p:sldLayoutId xmlns:r="http://schemas.openxmlformats.org/officeDocument/2006/relationships" id="2147483649" r:id="R331608b6371b4488"/>
+    <p:sldLayoutId xmlns:r="http://schemas.openxmlformats.org/officeDocument/2006/relationships" id="2147483649" r:id="R14f95d7655864968"/>
   </p:sldLayoutIdLst>
   <p:txStyles>
     <p:titleStyle>
@@ -2036,7 +2046,7 @@
                 <a:ea typeface="Calibri"/>
                 <a:cs typeface="Calibri"/>
               </a:rPr>
-              <a:t>CONTEXT COMPOSITION</a:t>
+              <a:t>SYSTEM BOUNDARIES</a:t>
             </a:r>
           </a:p>
         </p:txBody>
@@ -2093,7 +2103,7 @@
                 <a:ea typeface="Calibri"/>
                 <a:cs typeface="Calibri"/>
               </a:rPr>
-              <a:t>Context engineering controls what the model can see</a:t>
+              <a:t>Five mechanisms, five distinct responsibilities</a:t>
             </a:r>
           </a:p>
         </p:txBody>
@@ -2150,7 +2160,7 @@
                 <a:ea typeface="Calibri"/>
                 <a:cs typeface="Calibri"/>
               </a:rPr>
-              <a:t>STABLE POLICY</a:t>
+              <a:t>CONTEXT</a:t>
             </a:r>
           </a:p>
         </p:txBody>
@@ -2207,7 +2217,7 @@
                 <a:ea typeface="Calibri"/>
                 <a:cs typeface="Calibri"/>
               </a:rPr>
-              <a:t>Role, evidence rules and output contract</a:t>
+              <a:t>Information supplied to this model call</a:t>
             </a:r>
           </a:p>
         </p:txBody>
@@ -2297,7 +2307,7 @@
                 <a:ea typeface="Calibri"/>
                 <a:cs typeface="Calibri"/>
               </a:rPr>
-              <a:t>WORKING CONTEXT</a:t>
+              <a:t>CACHE</a:t>
             </a:r>
           </a:p>
         </p:txBody>
@@ -2354,7 +2364,7 @@
                 <a:ea typeface="Calibri"/>
                 <a:cs typeface="Calibri"/>
               </a:rPr>
-              <a:t>Complete document plus the current question</a:t>
+              <a:t>Reuse of an exact stable prefix</a:t>
             </a:r>
           </a:p>
         </p:txBody>
@@ -2446,7 +2456,7 @@
                 <a:ea typeface="Consolas"/>
                 <a:cs typeface="Consolas"/>
               </a:rPr>
-              <a:t>request = {</a:t>
+              <a:t>separate = {</a:t>
             </a:r>
           </a:p>
         </p:txBody>
@@ -2503,7 +2513,7 @@
                 <a:ea typeface="Consolas"/>
                 <a:cs typeface="Consolas"/>
               </a:rPr>
-              <a:t>  "instructions": stable_policy,</a:t>
+              <a:t>  "memory": interaction_state,</a:t>
             </a:r>
           </a:p>
         </p:txBody>
@@ -2560,7 +2570,7 @@
                 <a:ea typeface="Consolas"/>
                 <a:cs typeface="Consolas"/>
               </a:rPr>
-              <a:t>  "document": full_source,</a:t>
+              <a:t>  "grounding": evidence_support,</a:t>
             </a:r>
           </a:p>
         </p:txBody>
@@ -2617,7 +2627,7 @@
                 <a:ea typeface="Consolas"/>
                 <a:cs typeface="Consolas"/>
               </a:rPr>
-              <a:t>  "question": current_question  }</a:t>
+              <a:t>  "RAG": selected_evidence }</a:t>
             </a:r>
           </a:p>
         </p:txBody>
@@ -2674,7 +2684,7 @@
                 <a:ea typeface="Calibri"/>
                 <a:cs typeface="Calibri"/>
               </a:rPr>
-              <a:t>Budget the complete request—not the document in isolation.</a:t>
+              <a:t>Mechanisms can coexist; none is a synonym for another.</a:t>
             </a:r>
           </a:p>
         </p:txBody>
@@ -2854,7 +2864,7 @@
                 <a:ea typeface="Calibri"/>
                 <a:cs typeface="Calibri"/>
               </a:rPr>
-              <a:t>CONTEXT</a:t>
+              <a:t>BOUNDARIES</a:t>
             </a:r>
           </a:p>
         </p:txBody>
@@ -2997,7 +3007,7 @@
                 <a:ea typeface="Calibri"/>
                 <a:cs typeface="Calibri"/>
               </a:rPr>
-              <a:t>CAG ARCHITECTURE</a:t>
+              <a:t>ROUTING CONTRACT</a:t>
             </a:r>
           </a:p>
         </p:txBody>
@@ -3054,7 +3064,7 @@
                 <a:ea typeface="Calibri"/>
                 <a:cs typeface="Calibri"/>
               </a:rPr>
-              <a:t>A full-context answer passes through four explicit stages</a:t>
+              <a:t>ContextDecision makes the CAG/RAG gate inspectable</a:t>
             </a:r>
           </a:p>
         </p:txBody>
@@ -3168,7 +3178,7 @@
                 <a:ea typeface="Calibri"/>
                 <a:cs typeface="Calibri"/>
               </a:rPr>
-              <a:t>Complete document</a:t>
+              <a:t>Estimate complete input</a:t>
             </a:r>
           </a:p>
         </p:txBody>
@@ -3225,7 +3235,7 @@
                 <a:ea typeface="Calibri"/>
                 <a:cs typeface="Calibri"/>
               </a:rPr>
-              <a:t>LOAD</a:t>
+              <a:t>COUNT</a:t>
             </a:r>
           </a:p>
         </p:txBody>
@@ -3372,7 +3382,7 @@
                 <a:ea typeface="Calibri"/>
                 <a:cs typeface="Calibri"/>
               </a:rPr>
-              <a:t>Context budget</a:t>
+              <a:t>Compare available capacity</a:t>
             </a:r>
           </a:p>
         </p:txBody>
@@ -3429,7 +3439,7 @@
                 <a:ea typeface="Calibri"/>
                 <a:cs typeface="Calibri"/>
               </a:rPr>
-              <a:t>GATE</a:t>
+              <a:t>DECIDE</a:t>
             </a:r>
           </a:p>
         </p:txBody>
@@ -3576,7 +3586,7 @@
                 <a:ea typeface="Calibri"/>
                 <a:cs typeface="Calibri"/>
               </a:rPr>
-              <a:t>Stable prompt prefix</a:t>
+              <a:t>Return route + reason</a:t>
             </a:r>
           </a:p>
         </p:txBody>
@@ -3633,7 +3643,7 @@
                 <a:ea typeface="Calibri"/>
                 <a:cs typeface="Calibri"/>
               </a:rPr>
-              <a:t>REUSE</a:t>
+              <a:t>RECORD</a:t>
             </a:r>
           </a:p>
         </p:txBody>
@@ -3780,7 +3790,7 @@
                 <a:ea typeface="Calibri"/>
                 <a:cs typeface="Calibri"/>
               </a:rPr>
-              <a:t>Grounded model answer</a:t>
+              <a:t>Generate only after gate</a:t>
             </a:r>
           </a:p>
         </p:txBody>
@@ -3837,7 +3847,7 @@
                 <a:ea typeface="Calibri"/>
                 <a:cs typeface="Calibri"/>
               </a:rPr>
-              <a:t>VERIFY</a:t>
+              <a:t>RUN</a:t>
             </a:r>
           </a:p>
         </p:txBody>
@@ -3962,7 +3972,7 @@
                 <a:ea typeface="Calibri"/>
                 <a:cs typeface="Calibri"/>
               </a:rPr>
-              <a:t>BOUNDED SOURCE</a:t>
+              <a:t>TYPED STATE</a:t>
             </a:r>
           </a:p>
         </p:txBody>
@@ -4019,8 +4029,8 @@
                 <a:ea typeface="Calibri"/>
                 <a:cs typeface="Calibri"/>
               </a:rPr>
-              <a:t>CAG
-path</a:t>
+              <a:t>Context
+Decision</a:t>
             </a:r>
           </a:p>
         </p:txBody>
@@ -4077,8 +4087,8 @@
                 <a:ea typeface="Calibri"/>
                 <a:cs typeface="Calibri"/>
               </a:rPr>
-              <a:t>No retrieval.
-One complete source.</a:t>
+              <a:t>route · tokens
+reason</a:t>
             </a:r>
           </a:p>
         </p:txBody>
@@ -4135,7 +4145,7 @@
                 <a:ea typeface="Calibri"/>
                 <a:cs typeface="Calibri"/>
               </a:rPr>
-              <a:t>If the gate rejects the prompt, stop before the model call.</a:t>
+              <a:t>The same object becomes trace data in Lesson 07.</a:t>
             </a:r>
           </a:p>
         </p:txBody>
@@ -4315,7 +4325,7 @@
                 <a:ea typeface="Calibri"/>
                 <a:cs typeface="Calibri"/>
               </a:rPr>
-              <a:t>ARCHITECTURE</a:t>
+              <a:t>DECISION</a:t>
             </a:r>
           </a:p>
         </p:txBody>

</xml_diff>